<commit_message>
deck: add the repository and published-results screenshots
Captured from the pushed repo rather than mocked up: the file tree and the
rendered RESULTS.md headline-numbers table. They go on backup slide B8 beside
the path table, and a smaller crop of RESULTS.md on the closing slide, which
previously carried the claim that every number traces to raw data without
showing it.

Co-Authored-By: Claude Opus 5 <noreply@anthropic.com>
</commit_message>
<xml_diff>
--- a/docs/presentation.pptx
+++ b/docs/presentation.pptx
@@ -7807,8 +7807,8 @@
         </p:nvSpPr>
         <p:spPr>
           <a:xfrm>
-            <a:off x="640080" y="5943600"/>
-            <a:ext cx="10908792" cy="365760"/>
+            <a:off x="640080" y="5852160"/>
+            <a:ext cx="6858000" cy="292608"/>
           </a:xfrm>
           <a:prstGeom prst="rect">
             <a:avLst/>
@@ -7824,7 +7824,46 @@
               <a:buNone/>
             </a:pPr>
             <a:r>
-              <a:rPr lang="en-US" sz="1300" dirty="0">
+              <a:rPr lang="en-US" sz="1400" b="1" dirty="0">
+                <a:solidFill>
+                  <a:srgbClr val="8FB4E8"/>
+                </a:solidFill>
+                <a:latin typeface="Calibri" pitchFamily="34" charset="0"/>
+                <a:ea typeface="Calibri" pitchFamily="34" charset="-122"/>
+                <a:cs typeface="Calibri" pitchFamily="34" charset="-120"/>
+              </a:rPr>
+              <a:t>github.com/Sawaiz-zip/agentic-verilog-testbench</a:t>
+            </a:r>
+            <a:endParaRPr lang="en-US" sz="1400" dirty="0"/>
+          </a:p>
+        </p:txBody>
+      </p:sp>
+      <p:sp>
+        <p:nvSpPr>
+          <p:cNvPr id="13" name="Text 11"/>
+          <p:cNvSpPr txBox="1"/>
+          <p:nvPr/>
+        </p:nvSpPr>
+        <p:spPr>
+          <a:xfrm>
+            <a:off x="640080" y="6163056"/>
+            <a:ext cx="6858000" cy="292608"/>
+          </a:xfrm>
+          <a:prstGeom prst="rect">
+            <a:avLst/>
+          </a:prstGeom>
+          <a:noFill/>
+          <a:ln/>
+        </p:spPr>
+        <p:txBody>
+          <a:bodyPr wrap="square" lIns="0" tIns="0" rIns="0" bIns="0" rtlCol="0" anchor="ctr"/>
+          <a:lstStyle/>
+          <a:p>
+            <a:pPr indent="0" marL="0">
+              <a:buNone/>
+            </a:pPr>
+            <a:r>
+              <a:rPr lang="en-US" sz="1200" dirty="0">
                 <a:solidFill>
                   <a:srgbClr val="A8B6CE"/>
                 </a:solidFill>
@@ -7832,12 +7871,36 @@
                 <a:ea typeface="Calibri" pitchFamily="34" charset="-122"/>
                 <a:cs typeface="Calibri" pitchFamily="34" charset="-120"/>
               </a:rPr>
-              <a:t>github.com/Sawaiz-zip/agentic-verilog-testbench      ·      results/RESULTS.md traces every number in this talk to its raw data</a:t>
+              <a:t>results/RESULTS.md traces every number in this talk to its raw records</a:t>
             </a:r>
-            <a:endParaRPr lang="en-US" sz="1300" dirty="0"/>
+            <a:endParaRPr lang="en-US" sz="1200" dirty="0"/>
           </a:p>
         </p:txBody>
       </p:sp>
+      <p:pic>
+        <p:nvPicPr>
+          <p:cNvPr id="14" name="Image 0" descr="/Users/sawaiznaveed/Ilmenau Uni/ResearchProject/docs/figures/shots/results-md.jpg">    </p:cNvPr>
+          <p:cNvPicPr>
+            <a:picLocks noChangeAspect="1"/>
+          </p:cNvPicPr>
+          <p:nvPr/>
+        </p:nvPicPr>
+        <p:blipFill>
+          <a:blip r:embed="rId1"/>
+          <a:stretch>
+            <a:fillRect/>
+          </a:stretch>
+        </p:blipFill>
+        <p:spPr>
+          <a:xfrm>
+            <a:off x="7772400" y="1371600"/>
+            <a:ext cx="3776472" cy="1883664"/>
+          </a:xfrm>
+          <a:prstGeom prst="rect">
+            <a:avLst/>
+          </a:prstGeom>
+        </p:spPr>
+      </p:pic>
     </p:spTree>
   </p:cSld>
   <p:clrMapOvr>
@@ -17524,6 +17587,30 @@
           </a:p>
         </p:txBody>
       </p:sp>
+      <p:pic>
+        <p:nvPicPr>
+          <p:cNvPr id="5" name="Image 0" descr="/Users/sawaiznaveed/Ilmenau Uni/ResearchProject/docs/figures/shots/repo-tree.jpg">    </p:cNvPr>
+          <p:cNvPicPr>
+            <a:picLocks noChangeAspect="1"/>
+          </p:cNvPicPr>
+          <p:nvPr/>
+        </p:nvPicPr>
+        <p:blipFill>
+          <a:blip r:embed="rId1"/>
+          <a:stretch>
+            <a:fillRect/>
+          </a:stretch>
+        </p:blipFill>
+        <p:spPr>
+          <a:xfrm>
+            <a:off x="6903720" y="1600200"/>
+            <a:ext cx="4645152" cy="2313432"/>
+          </a:xfrm>
+          <a:prstGeom prst="rect">
+            <a:avLst/>
+          </a:prstGeom>
+        </p:spPr>
+      </p:pic>
       <p:graphicFrame>
         <p:nvGraphicFramePr>
           <p:cNvPr id="26" name="Table 0"/>
@@ -17540,15 +17627,15 @@
         </p:nvGraphicFramePr>
         <p:xfrm>
           <a:off x="640080" y="1600200"/>
-          <a:ext cx="10908792" cy="914400"/>
+          <a:ext cx="6035040" cy="914400"/>
         </p:xfrm>
         <a:graphic>
           <a:graphicData uri="http://schemas.openxmlformats.org/drawingml/2006/table">
             <a:tbl>
               <a:tblPr/>
               <a:tblGrid>
-                <a:gridCol w="3108960"/>
-                <a:gridCol w="7799832"/>
+                <a:gridCol w="2286000"/>
+                <a:gridCol w="3749040"/>
               </a:tblGrid>
               <a:tr h="310896">
                 <a:tc>
@@ -18520,9 +18607,33 @@
           </a:graphicData>
         </a:graphic>
       </p:graphicFrame>
-      <p:sp>
-        <p:nvSpPr>
-          <p:cNvPr id="6" name="Shape 3"/>
+      <p:pic>
+        <p:nvPicPr>
+          <p:cNvPr id="7" name="Image 1" descr="/Users/sawaiznaveed/Ilmenau Uni/ResearchProject/docs/figures/shots/results-md.jpg">    </p:cNvPr>
+          <p:cNvPicPr>
+            <a:picLocks noChangeAspect="1"/>
+          </p:cNvPicPr>
+          <p:nvPr/>
+        </p:nvPicPr>
+        <p:blipFill>
+          <a:blip r:embed="rId2"/>
+          <a:stretch>
+            <a:fillRect/>
+          </a:stretch>
+        </p:blipFill>
+        <p:spPr>
+          <a:xfrm>
+            <a:off x="6903720" y="4087368"/>
+            <a:ext cx="4645152" cy="2313432"/>
+          </a:xfrm>
+          <a:prstGeom prst="rect">
+            <a:avLst/>
+          </a:prstGeom>
+        </p:spPr>
+      </p:pic>
+      <p:sp>
+        <p:nvSpPr>
+          <p:cNvPr id="8" name="Shape 3"/>
           <p:cNvSpPr/>
           <p:nvPr/>
         </p:nvSpPr>
@@ -18556,7 +18667,7 @@
       </p:sp>
       <p:sp>
         <p:nvSpPr>
-          <p:cNvPr id="7" name="Text 4"/>
+          <p:cNvPr id="9" name="Text 4"/>
           <p:cNvSpPr txBox="1"/>
           <p:nvPr/>
         </p:nvSpPr>

</xml_diff>

<commit_message>
deck: keep the gen_checker slide descriptive
Reverts the previous change. The slide describes what the node writes, why the
structure is there, and that it is generated alongside the testbench rather than
after it. It makes no claim either way about what happens to the file later.

Co-Authored-By: Claude Opus 5 <noreply@anthropic.com>
</commit_message>
<xml_diff>
--- a/docs/presentation.pptx
+++ b/docs/presentation.pptx
@@ -799,10 +799,10 @@
           <a:p>
             <a:r>
               <a:rPr lang="en-US" dirty="0"/>
-              <a:t>BE STRAIGHT ABOUT THIS ONE — it is in the code and an examiner could find it. The generated checker is written, stored in every result record, and never executed. Evaluation parses the PASS and FAIL lines with a hand-written function, not this.
-WHY IT IS STILL THERE: we took the two-track design from AutoBench, then made the testbench self-checking, which made the Python track redundant. We left it in rather than remove it.
-IF ASKED which design is better: theirs separates the stimulus from the checking, which in principle allows more thorough checking; ours is simpler and closer to what engineers write. We did not test which is better, and I would not guess.
-IF ASKED why they run in parallel: both read the same inputs and neither needs the other's output, so overlapping them saves wall-clock time. Nothing is running at this point — both steps are writing files.</a:t>
+              <a:t>Thirty seconds. Nothing here produced a finding.
+NOT ON SLIDE — how this differs from AutoBench, worth one sentence: theirs is a bigger split. Their Verilog only drives the circuit and dumps what it sees to a text file, and Python does the judging. Ours is self-checking — the Verilog prints PASS or FAIL itself.
+Ours is simpler and closer to what engineers actually write. Theirs separates the stimulus from the checking, which in principle allows more thorough checking. We did not test which is better and I would not guess.
+IF ASKED why the two run in parallel: both read the same inputs and neither needs the other's output. Nothing is executing at this point — both steps are writing files.</a:t>
             </a:r>
             <a:endParaRPr lang="en-US" dirty="0"/>
           </a:p>
@@ -7387,7 +7387,7 @@
                 <a:ea typeface="Calibri" pitchFamily="34" charset="-122"/>
                 <a:cs typeface="Calibri" pitchFamily="34" charset="-120"/>
               </a:rPr>
-              <a:t>A Python checker — inherited, and unused</a:t>
+              <a:t>A Python checker, written alongside</a:t>
             </a:r>
             <a:endParaRPr lang="en-US" sz="1600" dirty="0"/>
           </a:p>
@@ -7502,7 +7502,7 @@
                 <a:ea typeface="Calibri" pitchFamily="34" charset="-122"/>
                 <a:cs typeface="Calibri" pitchFamily="34" charset="-120"/>
               </a:rPr>
-              <a:t>Reads the same spec and scenarios as the previous step and writes a small Python programme that could read the testbench's output and decide pass or fail.</a:t>
+              <a:t>Reads the same spec and scenarios as the previous step and writes a small Python programme for reading a testbench's output and deciding pass or fail.</a:t>
             </a:r>
             <a:endParaRPr lang="en-US" sz="1350" dirty="0"/>
           </a:p>
@@ -7617,7 +7617,7 @@
                 <a:ea typeface="Calibri" pitchFamily="34" charset="-122"/>
                 <a:cs typeface="Calibri" pitchFamily="34" charset="-120"/>
               </a:rPr>
-              <a:t>AutoBench splits the work this way: their Verilog only drives the circuit and dumps what it sees, and Python does all the judging. We copied the structure — then made our testbench judge itself, which left this track with nothing to do.</a:t>
+              <a:t>It comes from AutoBench's structure, where the Verilog drives the circuit and Python judges the result. It needs nothing from the testbench, so the two are generated at the same time.</a:t>
             </a:r>
             <a:endParaRPr lang="en-US" sz="1350" dirty="0"/>
           </a:p>
@@ -7923,7 +7923,7 @@
                 <a:ea typeface="Cambria" pitchFamily="34" charset="-122"/>
                 <a:cs typeface="Cambria" pitchFamily="34" charset="-120"/>
               </a:rPr>
-              <a:t>never run</a:t>
+              <a:t>in parallel</a:t>
             </a:r>
             <a:endParaRPr lang="en-US" sz="3100" dirty="0"/>
           </a:p>
@@ -7965,7 +7965,7 @@
                 <a:ea typeface="Calibri" pitchFamily="34" charset="-122"/>
                 <a:cs typeface="Calibri" pitchFamily="34" charset="-120"/>
               </a:rPr>
-              <a:t>the generated checker is stored</a:t>
+              <a:t>generated alongside the testbench,</a:t>
             </a:r>
             <a:endParaRPr lang="en-US" sz="1250" dirty="0"/>
           </a:p>
@@ -7985,7 +7985,7 @@
                 <a:ea typeface="Calibri" pitchFamily="34" charset="-122"/>
                 <a:cs typeface="Calibri" pitchFamily="34" charset="-120"/>
               </a:rPr>
-              <a:t>with each run and not executed</a:t>
+              <a:t>not after it</a:t>
             </a:r>
             <a:endParaRPr lang="en-US" sz="1250" dirty="0"/>
           </a:p>
@@ -8027,7 +8027,7 @@
                 <a:ea typeface="Calibri" pitchFamily="34" charset="-122"/>
                 <a:cs typeface="Calibri" pitchFamily="34" charset="-120"/>
               </a:rPr>
-              <a:t>Our testbench decides PASS or FAIL itself, so evaluation reads those lines directly. We report this as dead weight rather than a second opinion.</a:t>
+              <a:t>Ours carries less of the load than AutoBench's, because our testbench prints its own PASS and FAIL verdicts.</a:t>
             </a:r>
             <a:endParaRPr lang="en-US" sz="1300" dirty="0"/>
           </a:p>

</xml_diff>

<commit_message>
deck: name the six checks on the pyverilog_analysis slide
The slide said 'six checks' without ever listing them, which is the one thing an
audience actually wants from that node. They are now in the example panel with
what each catches.

Notes add two things the slide cannot carry: that this step is not part of
Eval0, 1 or 2 -- it runs before any of them, which is what 'early' means in the
title -- and the inference that ties the project together. The checker detects
all six in a controlled test and found almost nothing in 280 real runs; both
being true means the real testbenches did not contain these mistakes. That is a
statement about what current models produce, not about whether the tool works.

Co-Authored-By: Claude Opus 5 <noreply@anthropic.com>
</commit_message>
<xml_diff>
--- a/docs/presentation.pptx
+++ b/docs/presentation.pptx
@@ -1071,7 +1071,10 @@
             <a:r>
               <a:rPr lang="en-US" dirty="0"/>
               <a:t>Do NOT give the performance number here — the results slide has it. Set it up and move.
-IF ASKED about coverage: the parser could only read 262 of 434 files. The rest use newer SystemVerilog syntax it does not support and fall back to a second parser that only checks validity. Real limitation, in the report. Worse, those unreadable files are not a random sample — they fail Eval1 far more often, so our result is measured on the healthier half.
+THE TWO BOLD ROWS carry the argument. unobserved_output and missing_fdisplay are the ones nothing else can catch.
+WHAT THIS DOES NOT DO — worth being clear if asked: it is not part of Eval0, 1 or 2. It runs before any of them, before anything is compiled or simulated. That earliness is the whole point — “early error localisation” in the title.
+THE INFERENCE WORTH DRAWING, and it is the cleanest way to put the whole project: the checker detects 100% of these six in a controlled test, and in 280 real runs it found almost nothing. Both things being true means the real testbenches did not contain these mistakes. That is a statement about what current models produce, not about whether our tool works.
+IF ASKED about coverage: the parser could only read 262 of 434 files. The rest use newer SystemVerilog syntax it does not support and fall back to a second parser that only checks validity. Real limitation, in the report. Worse, those unreadable files fail Eval1 far more often, so our result is measured on the healthier half.
 IF ASKED whether we tuned the checks to flatter ourselves: we built seven and deleted one. It caught none of the five faults it was built for and raised the only false alarm on a correct testbench, so we removed it rather than patch it.</a:t>
             </a:r>
             <a:endParaRPr lang="en-US" dirty="0"/>
@@ -10931,7 +10934,7 @@
                 <a:ea typeface="Calibri" pitchFamily="34" charset="-122"/>
                 <a:cs typeface="Calibri" pitchFamily="34" charset="-120"/>
               </a:rPr>
-              <a:t>Parses the testbench and the circuit into a structure — not text — and runs six checks looking for mistakes. No simulation.</a:t>
+              <a:t>Parses the testbench and the circuit into a structure — not text — and runs six checks looking for mistakes. Nothing is simulated.</a:t>
             </a:r>
             <a:endParaRPr lang="en-US" sz="1350" dirty="0"/>
           </a:p>
@@ -11046,7 +11049,7 @@
                 <a:ea typeface="Calibri" pitchFamily="34" charset="-122"/>
                 <a:cs typeface="Calibri" pitchFamily="34" charset="-120"/>
               </a:rPr>
-              <a:t>Two of the six catch faults that nothing else can see: an output nobody checks, and a sequential output that is never printed. If the testbench stops looking, running it passes.</a:t>
+              <a:t>Two of the six catch faults that nothing else can see: an output nobody checks, and a clocked output that is never printed. If the testbench stops looking, running it passes.</a:t>
             </a:r>
             <a:endParaRPr lang="en-US" sz="1350" dirty="0"/>
           </a:p>
@@ -11158,7 +11161,7 @@
                 <a:ea typeface="Calibri" pitchFamily="34" charset="-122"/>
                 <a:cs typeface="Calibri" pitchFamily="34" charset="-120"/>
               </a:rPr>
-              <a:t>a real finding — Prob150, where the AI invented a clock pin</a:t>
+              <a:t>the six checks, and what each one catches</a:t>
             </a:r>
             <a:endParaRPr lang="en-US" sz="1150" dirty="0"/>
           </a:p>
@@ -11208,7 +11211,7 @@
                           <a:ea typeface="Calibri" pitchFamily="34" charset="-122"/>
                           <a:cs typeface="Calibri" pitchFamily="34" charset="-120"/>
                         </a:rPr>
-                        <a:t>field</a:t>
+                        <a:t>check</a:t>
                       </a:r>
                       <a:endParaRPr lang="en-US" sz="1250" dirty="0">
                         <a:latin typeface="Calibri" charset="0"/>
@@ -11276,7 +11279,7 @@
                           <a:ea typeface="Calibri" pitchFamily="34" charset="-122"/>
                           <a:cs typeface="Calibri" pitchFamily="34" charset="-120"/>
                         </a:rPr>
-                        <a:t>value</a:t>
+                        <a:t>catches</a:t>
                       </a:r>
                       <a:endParaRPr lang="en-US" sz="1250" dirty="0">
                         <a:latin typeface="Calibri" charset="0"/>
@@ -11329,74 +11332,6 @@
                 </a:tc>
               </a:tr>
               <a:tr h="246888">
-                <a:tc>
-                  <a:txBody>
-                    <a:bodyPr/>
-                    <a:lstStyle/>
-                    <a:p>
-                      <a:pPr indent="0" marL="0">
-                        <a:buNone/>
-                      </a:pPr>
-                      <a:r>
-                        <a:rPr lang="en-US" sz="1250" dirty="0">
-                          <a:solidFill>
-                            <a:srgbClr val="0B0B0B"/>
-                          </a:solidFill>
-                          <a:latin typeface="Calibri" pitchFamily="34" charset="0"/>
-                          <a:ea typeface="Calibri" pitchFamily="34" charset="-122"/>
-                          <a:cs typeface="Calibri" pitchFamily="34" charset="-120"/>
-                        </a:rPr>
-                        <a:t>error_type</a:t>
-                      </a:r>
-                      <a:endParaRPr lang="en-US" sz="1250" dirty="0">
-                        <a:latin typeface="Calibri" charset="0"/>
-                        <a:ea typeface="Calibri" charset="0"/>
-                        <a:cs typeface="Calibri" charset="0"/>
-                      </a:endParaRPr>
-                    </a:p>
-                  </a:txBody>
-                  <a:tcPr marL="50800" marR="50800" marT="50800" marB="50800" anchor="ctr">
-                    <a:lnL w="12700" cap="flat" cmpd="sng" algn="ctr">
-                      <a:solidFill>
-                        <a:srgbClr val="E2E1DC"/>
-                      </a:solidFill>
-                      <a:prstDash val="solid"/>
-                      <a:round/>
-                      <a:headEnd type="none" w="med" len="med"/>
-                      <a:tailEnd type="none" w="med" len="med"/>
-                    </a:lnL>
-                    <a:lnR w="12700" cap="flat" cmpd="sng" algn="ctr">
-                      <a:solidFill>
-                        <a:srgbClr val="E2E1DC"/>
-                      </a:solidFill>
-                      <a:prstDash val="solid"/>
-                      <a:round/>
-                      <a:headEnd type="none" w="med" len="med"/>
-                      <a:tailEnd type="none" w="med" len="med"/>
-                    </a:lnR>
-                    <a:lnT w="12700" cap="flat" cmpd="sng" algn="ctr">
-                      <a:solidFill>
-                        <a:srgbClr val="E2E1DC"/>
-                      </a:solidFill>
-                      <a:prstDash val="solid"/>
-                      <a:round/>
-                      <a:headEnd type="none" w="med" len="med"/>
-                      <a:tailEnd type="none" w="med" len="med"/>
-                    </a:lnT>
-                    <a:lnB w="12700" cap="flat" cmpd="sng" algn="ctr">
-                      <a:solidFill>
-                        <a:srgbClr val="E2E1DC"/>
-                      </a:solidFill>
-                      <a:prstDash val="solid"/>
-                      <a:round/>
-                      <a:headEnd type="none" w="med" len="med"/>
-                      <a:tailEnd type="none" w="med" len="med"/>
-                    </a:lnB>
-                    <a:solidFill>
-                      <a:srgbClr val="FFFFFF"/>
-                    </a:solidFill>
-                  </a:tcPr>
-                </a:tc>
                 <a:tc>
                   <a:txBody>
                     <a:bodyPr/>
@@ -11465,8 +11400,6 @@
                     </a:solidFill>
                   </a:tcPr>
                 </a:tc>
-              </a:tr>
-              <a:tr h="246888">
                 <a:tc>
                   <a:txBody>
                     <a:bodyPr/>
@@ -11484,75 +11417,7 @@
                           <a:ea typeface="Calibri" pitchFamily="34" charset="-122"/>
                           <a:cs typeface="Calibri" pitchFamily="34" charset="-120"/>
                         </a:rPr>
-                        <a:t>affected_signal</a:t>
-                      </a:r>
-                      <a:endParaRPr lang="en-US" sz="1250" dirty="0">
-                        <a:latin typeface="Calibri" charset="0"/>
-                        <a:ea typeface="Calibri" charset="0"/>
-                        <a:cs typeface="Calibri" charset="0"/>
-                      </a:endParaRPr>
-                    </a:p>
-                  </a:txBody>
-                  <a:tcPr marL="50800" marR="50800" marT="50800" marB="50800" anchor="ctr">
-                    <a:lnL w="12700" cap="flat" cmpd="sng" algn="ctr">
-                      <a:solidFill>
-                        <a:srgbClr val="E2E1DC"/>
-                      </a:solidFill>
-                      <a:prstDash val="solid"/>
-                      <a:round/>
-                      <a:headEnd type="none" w="med" len="med"/>
-                      <a:tailEnd type="none" w="med" len="med"/>
-                    </a:lnL>
-                    <a:lnR w="12700" cap="flat" cmpd="sng" algn="ctr">
-                      <a:solidFill>
-                        <a:srgbClr val="E2E1DC"/>
-                      </a:solidFill>
-                      <a:prstDash val="solid"/>
-                      <a:round/>
-                      <a:headEnd type="none" w="med" len="med"/>
-                      <a:tailEnd type="none" w="med" len="med"/>
-                    </a:lnR>
-                    <a:lnT w="12700" cap="flat" cmpd="sng" algn="ctr">
-                      <a:solidFill>
-                        <a:srgbClr val="E2E1DC"/>
-                      </a:solidFill>
-                      <a:prstDash val="solid"/>
-                      <a:round/>
-                      <a:headEnd type="none" w="med" len="med"/>
-                      <a:tailEnd type="none" w="med" len="med"/>
-                    </a:lnT>
-                    <a:lnB w="12700" cap="flat" cmpd="sng" algn="ctr">
-                      <a:solidFill>
-                        <a:srgbClr val="E2E1DC"/>
-                      </a:solidFill>
-                      <a:prstDash val="solid"/>
-                      <a:round/>
-                      <a:headEnd type="none" w="med" len="med"/>
-                      <a:tailEnd type="none" w="med" len="med"/>
-                    </a:lnB>
-                    <a:solidFill>
-                      <a:srgbClr val="FFFFFF"/>
-                    </a:solidFill>
-                  </a:tcPr>
-                </a:tc>
-                <a:tc>
-                  <a:txBody>
-                    <a:bodyPr/>
-                    <a:lstStyle/>
-                    <a:p>
-                      <a:pPr indent="0" marL="0">
-                        <a:buNone/>
-                      </a:pPr>
-                      <a:r>
-                        <a:rPr lang="en-US" sz="1250" dirty="0">
-                          <a:solidFill>
-                            <a:srgbClr val="0B0B0B"/>
-                          </a:solidFill>
-                          <a:latin typeface="Calibri" pitchFamily="34" charset="0"/>
-                          <a:ea typeface="Calibri" pitchFamily="34" charset="-122"/>
-                          <a:cs typeface="Calibri" pitchFamily="34" charset="-120"/>
-                        </a:rPr>
-                        <a:t>clk</a:t>
+                        <a:t>a pin wired to the wrong name</a:t>
                       </a:r>
                       <a:endParaRPr lang="en-US" sz="1250" dirty="0">
                         <a:latin typeface="Calibri" charset="0"/>
@@ -11622,7 +11487,7 @@
                           <a:ea typeface="Calibri" pitchFamily="34" charset="-122"/>
                           <a:cs typeface="Calibri" pitchFamily="34" charset="-120"/>
                         </a:rPr>
-                        <a:t>severity</a:t>
+                        <a:t>width_mismatch</a:t>
                       </a:r>
                       <a:endParaRPr lang="en-US" sz="1250" dirty="0">
                         <a:latin typeface="Calibri" charset="0"/>
@@ -11690,7 +11555,7 @@
                           <a:ea typeface="Calibri" pitchFamily="34" charset="-122"/>
                           <a:cs typeface="Calibri" pitchFamily="34" charset="-120"/>
                         </a:rPr>
-                        <a:t>ERROR</a:t>
+                        <a:t>a 3-bit signal in a 4-bit port</a:t>
                       </a:r>
                       <a:endParaRPr lang="en-US" sz="1250" dirty="0">
                         <a:latin typeface="Calibri" charset="0"/>
@@ -11760,7 +11625,7 @@
                           <a:ea typeface="Calibri" pitchFamily="34" charset="-122"/>
                           <a:cs typeface="Calibri" pitchFamily="34" charset="-120"/>
                         </a:rPr>
-                        <a:t>found by</a:t>
+                        <a:t>undriven_input</a:t>
                       </a:r>
                       <a:endParaRPr lang="en-US" sz="1250" dirty="0">
                         <a:latin typeface="Calibri" charset="0"/>
@@ -11828,7 +11693,421 @@
                           <a:ea typeface="Calibri" pitchFamily="34" charset="-122"/>
                           <a:cs typeface="Calibri" pitchFamily="34" charset="-120"/>
                         </a:rPr>
-                        <a:t>reading the code, before running</a:t>
+                        <a:t>an input never given a value</a:t>
+                      </a:r>
+                      <a:endParaRPr lang="en-US" sz="1250" dirty="0">
+                        <a:latin typeface="Calibri" charset="0"/>
+                        <a:ea typeface="Calibri" charset="0"/>
+                        <a:cs typeface="Calibri" charset="0"/>
+                      </a:endParaRPr>
+                    </a:p>
+                  </a:txBody>
+                  <a:tcPr marL="50800" marR="50800" marT="50800" marB="50800" anchor="ctr">
+                    <a:lnL w="12700" cap="flat" cmpd="sng" algn="ctr">
+                      <a:solidFill>
+                        <a:srgbClr val="E2E1DC"/>
+                      </a:solidFill>
+                      <a:prstDash val="solid"/>
+                      <a:round/>
+                      <a:headEnd type="none" w="med" len="med"/>
+                      <a:tailEnd type="none" w="med" len="med"/>
+                    </a:lnL>
+                    <a:lnR w="12700" cap="flat" cmpd="sng" algn="ctr">
+                      <a:solidFill>
+                        <a:srgbClr val="E2E1DC"/>
+                      </a:solidFill>
+                      <a:prstDash val="solid"/>
+                      <a:round/>
+                      <a:headEnd type="none" w="med" len="med"/>
+                      <a:tailEnd type="none" w="med" len="med"/>
+                    </a:lnR>
+                    <a:lnT w="12700" cap="flat" cmpd="sng" algn="ctr">
+                      <a:solidFill>
+                        <a:srgbClr val="E2E1DC"/>
+                      </a:solidFill>
+                      <a:prstDash val="solid"/>
+                      <a:round/>
+                      <a:headEnd type="none" w="med" len="med"/>
+                      <a:tailEnd type="none" w="med" len="med"/>
+                    </a:lnT>
+                    <a:lnB w="12700" cap="flat" cmpd="sng" algn="ctr">
+                      <a:solidFill>
+                        <a:srgbClr val="E2E1DC"/>
+                      </a:solidFill>
+                      <a:prstDash val="solid"/>
+                      <a:round/>
+                      <a:headEnd type="none" w="med" len="med"/>
+                      <a:tailEnd type="none" w="med" len="med"/>
+                    </a:lnB>
+                    <a:solidFill>
+                      <a:srgbClr val="FFFFFF"/>
+                    </a:solidFill>
+                  </a:tcPr>
+                </a:tc>
+              </a:tr>
+              <a:tr h="246888">
+                <a:tc>
+                  <a:txBody>
+                    <a:bodyPr/>
+                    <a:lstStyle/>
+                    <a:p>
+                      <a:pPr indent="0" marL="0">
+                        <a:buNone/>
+                      </a:pPr>
+                      <a:r>
+                        <a:rPr lang="en-US" sz="1250" dirty="0">
+                          <a:solidFill>
+                            <a:srgbClr val="0B0B0B"/>
+                          </a:solidFill>
+                          <a:latin typeface="Calibri" pitchFamily="34" charset="0"/>
+                          <a:ea typeface="Calibri" pitchFamily="34" charset="-122"/>
+                          <a:cs typeface="Calibri" pitchFamily="34" charset="-120"/>
+                        </a:rPr>
+                        <a:t>unobserved_output</a:t>
+                      </a:r>
+                      <a:endParaRPr lang="en-US" sz="1250" dirty="0">
+                        <a:latin typeface="Calibri" charset="0"/>
+                        <a:ea typeface="Calibri" charset="0"/>
+                        <a:cs typeface="Calibri" charset="0"/>
+                      </a:endParaRPr>
+                    </a:p>
+                  </a:txBody>
+                  <a:tcPr marL="50800" marR="50800" marT="50800" marB="50800" anchor="ctr">
+                    <a:lnL w="12700" cap="flat" cmpd="sng" algn="ctr">
+                      <a:solidFill>
+                        <a:srgbClr val="E2E1DC"/>
+                      </a:solidFill>
+                      <a:prstDash val="solid"/>
+                      <a:round/>
+                      <a:headEnd type="none" w="med" len="med"/>
+                      <a:tailEnd type="none" w="med" len="med"/>
+                    </a:lnL>
+                    <a:lnR w="12700" cap="flat" cmpd="sng" algn="ctr">
+                      <a:solidFill>
+                        <a:srgbClr val="E2E1DC"/>
+                      </a:solidFill>
+                      <a:prstDash val="solid"/>
+                      <a:round/>
+                      <a:headEnd type="none" w="med" len="med"/>
+                      <a:tailEnd type="none" w="med" len="med"/>
+                    </a:lnR>
+                    <a:lnT w="12700" cap="flat" cmpd="sng" algn="ctr">
+                      <a:solidFill>
+                        <a:srgbClr val="E2E1DC"/>
+                      </a:solidFill>
+                      <a:prstDash val="solid"/>
+                      <a:round/>
+                      <a:headEnd type="none" w="med" len="med"/>
+                      <a:tailEnd type="none" w="med" len="med"/>
+                    </a:lnT>
+                    <a:lnB w="12700" cap="flat" cmpd="sng" algn="ctr">
+                      <a:solidFill>
+                        <a:srgbClr val="E2E1DC"/>
+                      </a:solidFill>
+                      <a:prstDash val="solid"/>
+                      <a:round/>
+                      <a:headEnd type="none" w="med" len="med"/>
+                      <a:tailEnd type="none" w="med" len="med"/>
+                    </a:lnB>
+                    <a:solidFill>
+                      <a:srgbClr val="FFFFFF"/>
+                    </a:solidFill>
+                  </a:tcPr>
+                </a:tc>
+                <a:tc>
+                  <a:txBody>
+                    <a:bodyPr/>
+                    <a:lstStyle/>
+                    <a:p>
+                      <a:pPr indent="0" marL="0">
+                        <a:buNone/>
+                      </a:pPr>
+                      <a:r>
+                        <a:rPr lang="en-US" sz="1250" dirty="0">
+                          <a:solidFill>
+                            <a:srgbClr val="0B0B0B"/>
+                          </a:solidFill>
+                          <a:latin typeface="Calibri" pitchFamily="34" charset="0"/>
+                          <a:ea typeface="Calibri" pitchFamily="34" charset="-122"/>
+                          <a:cs typeface="Calibri" pitchFamily="34" charset="-120"/>
+                        </a:rPr>
+                        <a:t>an output nobody ever checks</a:t>
+                      </a:r>
+                      <a:endParaRPr lang="en-US" sz="1250" dirty="0">
+                        <a:latin typeface="Calibri" charset="0"/>
+                        <a:ea typeface="Calibri" charset="0"/>
+                        <a:cs typeface="Calibri" charset="0"/>
+                      </a:endParaRPr>
+                    </a:p>
+                  </a:txBody>
+                  <a:tcPr marL="50800" marR="50800" marT="50800" marB="50800" anchor="ctr">
+                    <a:lnL w="12700" cap="flat" cmpd="sng" algn="ctr">
+                      <a:solidFill>
+                        <a:srgbClr val="E2E1DC"/>
+                      </a:solidFill>
+                      <a:prstDash val="solid"/>
+                      <a:round/>
+                      <a:headEnd type="none" w="med" len="med"/>
+                      <a:tailEnd type="none" w="med" len="med"/>
+                    </a:lnL>
+                    <a:lnR w="12700" cap="flat" cmpd="sng" algn="ctr">
+                      <a:solidFill>
+                        <a:srgbClr val="E2E1DC"/>
+                      </a:solidFill>
+                      <a:prstDash val="solid"/>
+                      <a:round/>
+                      <a:headEnd type="none" w="med" len="med"/>
+                      <a:tailEnd type="none" w="med" len="med"/>
+                    </a:lnR>
+                    <a:lnT w="12700" cap="flat" cmpd="sng" algn="ctr">
+                      <a:solidFill>
+                        <a:srgbClr val="E2E1DC"/>
+                      </a:solidFill>
+                      <a:prstDash val="solid"/>
+                      <a:round/>
+                      <a:headEnd type="none" w="med" len="med"/>
+                      <a:tailEnd type="none" w="med" len="med"/>
+                    </a:lnT>
+                    <a:lnB w="12700" cap="flat" cmpd="sng" algn="ctr">
+                      <a:solidFill>
+                        <a:srgbClr val="E2E1DC"/>
+                      </a:solidFill>
+                      <a:prstDash val="solid"/>
+                      <a:round/>
+                      <a:headEnd type="none" w="med" len="med"/>
+                      <a:tailEnd type="none" w="med" len="med"/>
+                    </a:lnB>
+                    <a:solidFill>
+                      <a:srgbClr val="FFFFFF"/>
+                    </a:solidFill>
+                  </a:tcPr>
+                </a:tc>
+              </a:tr>
+              <a:tr h="246888">
+                <a:tc>
+                  <a:txBody>
+                    <a:bodyPr/>
+                    <a:lstStyle/>
+                    <a:p>
+                      <a:pPr indent="0" marL="0">
+                        <a:buNone/>
+                      </a:pPr>
+                      <a:r>
+                        <a:rPr lang="en-US" sz="1250" dirty="0">
+                          <a:solidFill>
+                            <a:srgbClr val="0B0B0B"/>
+                          </a:solidFill>
+                          <a:latin typeface="Calibri" pitchFamily="34" charset="0"/>
+                          <a:ea typeface="Calibri" pitchFamily="34" charset="-122"/>
+                          <a:cs typeface="Calibri" pitchFamily="34" charset="-120"/>
+                        </a:rPr>
+                        <a:t>missing_fdisplay</a:t>
+                      </a:r>
+                      <a:endParaRPr lang="en-US" sz="1250" dirty="0">
+                        <a:latin typeface="Calibri" charset="0"/>
+                        <a:ea typeface="Calibri" charset="0"/>
+                        <a:cs typeface="Calibri" charset="0"/>
+                      </a:endParaRPr>
+                    </a:p>
+                  </a:txBody>
+                  <a:tcPr marL="50800" marR="50800" marT="50800" marB="50800" anchor="ctr">
+                    <a:lnL w="12700" cap="flat" cmpd="sng" algn="ctr">
+                      <a:solidFill>
+                        <a:srgbClr val="E2E1DC"/>
+                      </a:solidFill>
+                      <a:prstDash val="solid"/>
+                      <a:round/>
+                      <a:headEnd type="none" w="med" len="med"/>
+                      <a:tailEnd type="none" w="med" len="med"/>
+                    </a:lnL>
+                    <a:lnR w="12700" cap="flat" cmpd="sng" algn="ctr">
+                      <a:solidFill>
+                        <a:srgbClr val="E2E1DC"/>
+                      </a:solidFill>
+                      <a:prstDash val="solid"/>
+                      <a:round/>
+                      <a:headEnd type="none" w="med" len="med"/>
+                      <a:tailEnd type="none" w="med" len="med"/>
+                    </a:lnR>
+                    <a:lnT w="12700" cap="flat" cmpd="sng" algn="ctr">
+                      <a:solidFill>
+                        <a:srgbClr val="E2E1DC"/>
+                      </a:solidFill>
+                      <a:prstDash val="solid"/>
+                      <a:round/>
+                      <a:headEnd type="none" w="med" len="med"/>
+                      <a:tailEnd type="none" w="med" len="med"/>
+                    </a:lnT>
+                    <a:lnB w="12700" cap="flat" cmpd="sng" algn="ctr">
+                      <a:solidFill>
+                        <a:srgbClr val="E2E1DC"/>
+                      </a:solidFill>
+                      <a:prstDash val="solid"/>
+                      <a:round/>
+                      <a:headEnd type="none" w="med" len="med"/>
+                      <a:tailEnd type="none" w="med" len="med"/>
+                    </a:lnB>
+                    <a:solidFill>
+                      <a:srgbClr val="FFFFFF"/>
+                    </a:solidFill>
+                  </a:tcPr>
+                </a:tc>
+                <a:tc>
+                  <a:txBody>
+                    <a:bodyPr/>
+                    <a:lstStyle/>
+                    <a:p>
+                      <a:pPr indent="0" marL="0">
+                        <a:buNone/>
+                      </a:pPr>
+                      <a:r>
+                        <a:rPr lang="en-US" sz="1250" dirty="0">
+                          <a:solidFill>
+                            <a:srgbClr val="0B0B0B"/>
+                          </a:solidFill>
+                          <a:latin typeface="Calibri" pitchFamily="34" charset="0"/>
+                          <a:ea typeface="Calibri" pitchFamily="34" charset="-122"/>
+                          <a:cs typeface="Calibri" pitchFamily="34" charset="-120"/>
+                        </a:rPr>
+                        <a:t>a clocked output never printed</a:t>
+                      </a:r>
+                      <a:endParaRPr lang="en-US" sz="1250" dirty="0">
+                        <a:latin typeface="Calibri" charset="0"/>
+                        <a:ea typeface="Calibri" charset="0"/>
+                        <a:cs typeface="Calibri" charset="0"/>
+                      </a:endParaRPr>
+                    </a:p>
+                  </a:txBody>
+                  <a:tcPr marL="50800" marR="50800" marT="50800" marB="50800" anchor="ctr">
+                    <a:lnL w="12700" cap="flat" cmpd="sng" algn="ctr">
+                      <a:solidFill>
+                        <a:srgbClr val="E2E1DC"/>
+                      </a:solidFill>
+                      <a:prstDash val="solid"/>
+                      <a:round/>
+                      <a:headEnd type="none" w="med" len="med"/>
+                      <a:tailEnd type="none" w="med" len="med"/>
+                    </a:lnL>
+                    <a:lnR w="12700" cap="flat" cmpd="sng" algn="ctr">
+                      <a:solidFill>
+                        <a:srgbClr val="E2E1DC"/>
+                      </a:solidFill>
+                      <a:prstDash val="solid"/>
+                      <a:round/>
+                      <a:headEnd type="none" w="med" len="med"/>
+                      <a:tailEnd type="none" w="med" len="med"/>
+                    </a:lnR>
+                    <a:lnT w="12700" cap="flat" cmpd="sng" algn="ctr">
+                      <a:solidFill>
+                        <a:srgbClr val="E2E1DC"/>
+                      </a:solidFill>
+                      <a:prstDash val="solid"/>
+                      <a:round/>
+                      <a:headEnd type="none" w="med" len="med"/>
+                      <a:tailEnd type="none" w="med" len="med"/>
+                    </a:lnT>
+                    <a:lnB w="12700" cap="flat" cmpd="sng" algn="ctr">
+                      <a:solidFill>
+                        <a:srgbClr val="E2E1DC"/>
+                      </a:solidFill>
+                      <a:prstDash val="solid"/>
+                      <a:round/>
+                      <a:headEnd type="none" w="med" len="med"/>
+                      <a:tailEnd type="none" w="med" len="med"/>
+                    </a:lnB>
+                    <a:solidFill>
+                      <a:srgbClr val="FFFFFF"/>
+                    </a:solidFill>
+                  </a:tcPr>
+                </a:tc>
+              </a:tr>
+              <a:tr h="246888">
+                <a:tc>
+                  <a:txBody>
+                    <a:bodyPr/>
+                    <a:lstStyle/>
+                    <a:p>
+                      <a:pPr indent="0" marL="0">
+                        <a:buNone/>
+                      </a:pPr>
+                      <a:r>
+                        <a:rPr lang="en-US" sz="1250" dirty="0">
+                          <a:solidFill>
+                            <a:srgbClr val="0B0B0B"/>
+                          </a:solidFill>
+                          <a:latin typeface="Calibri" pitchFamily="34" charset="0"/>
+                          <a:ea typeface="Calibri" pitchFamily="34" charset="-122"/>
+                          <a:cs typeface="Calibri" pitchFamily="34" charset="-120"/>
+                        </a:rPr>
+                        <a:t>clock_never_toggled</a:t>
+                      </a:r>
+                      <a:endParaRPr lang="en-US" sz="1250" dirty="0">
+                        <a:latin typeface="Calibri" charset="0"/>
+                        <a:ea typeface="Calibri" charset="0"/>
+                        <a:cs typeface="Calibri" charset="0"/>
+                      </a:endParaRPr>
+                    </a:p>
+                  </a:txBody>
+                  <a:tcPr marL="50800" marR="50800" marT="50800" marB="50800" anchor="ctr">
+                    <a:lnL w="12700" cap="flat" cmpd="sng" algn="ctr">
+                      <a:solidFill>
+                        <a:srgbClr val="E2E1DC"/>
+                      </a:solidFill>
+                      <a:prstDash val="solid"/>
+                      <a:round/>
+                      <a:headEnd type="none" w="med" len="med"/>
+                      <a:tailEnd type="none" w="med" len="med"/>
+                    </a:lnL>
+                    <a:lnR w="12700" cap="flat" cmpd="sng" algn="ctr">
+                      <a:solidFill>
+                        <a:srgbClr val="E2E1DC"/>
+                      </a:solidFill>
+                      <a:prstDash val="solid"/>
+                      <a:round/>
+                      <a:headEnd type="none" w="med" len="med"/>
+                      <a:tailEnd type="none" w="med" len="med"/>
+                    </a:lnR>
+                    <a:lnT w="12700" cap="flat" cmpd="sng" algn="ctr">
+                      <a:solidFill>
+                        <a:srgbClr val="E2E1DC"/>
+                      </a:solidFill>
+                      <a:prstDash val="solid"/>
+                      <a:round/>
+                      <a:headEnd type="none" w="med" len="med"/>
+                      <a:tailEnd type="none" w="med" len="med"/>
+                    </a:lnT>
+                    <a:lnB w="12700" cap="flat" cmpd="sng" algn="ctr">
+                      <a:solidFill>
+                        <a:srgbClr val="E2E1DC"/>
+                      </a:solidFill>
+                      <a:prstDash val="solid"/>
+                      <a:round/>
+                      <a:headEnd type="none" w="med" len="med"/>
+                      <a:tailEnd type="none" w="med" len="med"/>
+                    </a:lnB>
+                    <a:solidFill>
+                      <a:srgbClr val="FFFFFF"/>
+                    </a:solidFill>
+                  </a:tcPr>
+                </a:tc>
+                <a:tc>
+                  <a:txBody>
+                    <a:bodyPr/>
+                    <a:lstStyle/>
+                    <a:p>
+                      <a:pPr indent="0" marL="0">
+                        <a:buNone/>
+                      </a:pPr>
+                      <a:r>
+                        <a:rPr lang="en-US" sz="1250" dirty="0">
+                          <a:solidFill>
+                            <a:srgbClr val="0B0B0B"/>
+                          </a:solidFill>
+                          <a:latin typeface="Calibri" pitchFamily="34" charset="0"/>
+                          <a:ea typeface="Calibri" pitchFamily="34" charset="-122"/>
+                          <a:cs typeface="Calibri" pitchFamily="34" charset="-120"/>
+                        </a:rPr>
+                        <a:t>a clock that never ticks</a:t>
                       </a:r>
                       <a:endParaRPr lang="en-US" sz="1250" dirty="0">
                         <a:latin typeface="Calibri" charset="0"/>
@@ -12094,7 +12373,7 @@
                 <a:ea typeface="Calibri" pitchFamily="34" charset="-122"/>
                 <a:cs typeface="Calibri" pitchFamily="34" charset="-120"/>
               </a:rPr>
-              <a:t>Zero false alarms on clean testbenches. This is the core contribution.</a:t>
+              <a:t>Zero false alarms on clean testbenches. This is the core contribution — the next section shows how we measured it.</a:t>
             </a:r>
             <a:endParaRPr lang="en-US" sz="1300" dirty="0"/>
           </a:p>

</xml_diff>

<commit_message>
deck: give slide 21 a reason for every number in its notes
The comparison table carries eight figures and the notes explained none of them.
They now say where each comes from, including the two that invite a wrong
reading: why 92.5 and 98.7 differ (pooled versus strong model only), and that
95 and 20 are not the same measurement on different circuits -- the circuits
changed AND the scoring rule changed, with raw detection on their circuits at
roughly 60% sitting between the two.

Also defines the two terms the slide uses without explaining: clocked, and what
n=20 means for how much the 20-versus-26 gap can be trusted.

Co-Authored-By: Claude Opus 5 <noreply@anthropic.com>
</commit_message>
<xml_diff>
--- a/docs/presentation.pptx
+++ b/docs/presentation.pptx
@@ -1701,8 +1701,17 @@
           <a:p>
             <a:r>
               <a:rPr lang="en-US" dirty="0"/>
-              <a:t>NOT ON SLIDE — the pilot behind the Eval2 claim was pre-registered: we wrote down the criteria before generating anything. Better broken copies moved the score one point; different circuits moved it forty-four.
-IF ASKED about sample size: 20 circuits, so the interval on that 20% runs roughly 8 to 42 percent. Their 26 sits inside it. No ranking is established in either direction, and I would not claim one.</a:t>
+              <a:t>WHERE EACH NUMBER COMES FROM, in case any one of them is queried.
+92.5% — our compile rate pooled over both models. Half our runs deliberately used a cheap model they never tested, which drags it down.
+98.7% — the same measure on the strong model alone. That is the like-for-like comparison with their 95.7%, because they used one good model throughout.
+31.4% — our pass rate against the real circuit, pooled. Low because these are the hardest fifth of their benchmark and three quarters of them are clocked, meaning the circuit has memory and a clock. Clocked circuits are the hard case for everyone: you have to get the timing right as well as the values.
+51.5% and 37.1% — theirs, across all circuits and across clocked ones only. Compare against 37.1, not 51.5.
+95% — our broken-copy detection. This counts individual broken copies caught, on our own small circuits. A one-bit flip-flop has nowhere for a bug to hide, so almost everything gets caught. It is a ceiling, not a result.
+44.8% — theirs, and NOT the same measure. They count a circuit as passed only if the testbench agrees with a reference testbench on at least 80% of the broken copies. Per-circuit with a threshold, against our per-copy raw rate.
+20% — our runs scored under their rule instead of ours: 4 of the 20 benchmark circuits cleared their 80% bar. That is the only honest comparison on this row, and it goes against their 26%.
+IF ASKED WHAT CHANGED BETWEEN 95 AND 20 — two things at once, so do not let it be read as one. The circuits got harder AND the scoring rule changed. The number that separates them is our raw detection on their circuits: about 54% with the weak model and 67% with the strong one. So harder circuits take it from 95 to roughly 60, and their stricter rule takes it from there to 20.
+IF ASKED WHAT n=20 MEANS: we tested 20 circuits, so 20% is 4 of them. With a sample that small the true value could plausibly sit anywhere from about 8% to 42%. Their 26% is inside that range, so neither of us is measurably ahead. I would not claim a ranking from 20 circuits and I do not.
+NOT ON SLIDE: the pilot behind the ceiling claim was pre-registered — we wrote the criteria down before generating anything. Better broken copies moved the score one point; different circuits moved it forty-four.</a:t>
             </a:r>
             <a:endParaRPr lang="en-US" dirty="0"/>
           </a:p>

</xml_diff>